<commit_message>
standardize to American English spelling across all modules and build scripts
Replaces British spellings throughout all markdown files and JS build scripts:
  artefact  → artifact
  behaviour → behavior
  programme → program
  organisation → organization
  organise  → organize
  prioritise → prioritize
  emphasise → emphasize
  maximise  → maximize
  minimise  → minimize
  recognise → recognize
  utilise   → utilize
  centre    → center
  cancelled → canceled

Affects all 13 markdown files and all 12 JS build scripts. All slides rebuilt.

Co-Authored-By: Claude Sonnet 4.6 <noreply@anthropic.com>
</commit_message>
<xml_diff>
--- a/slides/Module_01_Chat_vs_Agents_v2.pptx
+++ b/slides/Module_01_Chat_vs_Agents_v2.pptx
@@ -4913,7 +4913,7 @@
                   <a:srgbClr val="D4E4F0"/>
                 </a:solidFill>
               </a:rPr>
-              <a:t>Q4.  How does your organisation's risk culture affect where you set your HITL gates?</a:t>
+              <a:t>Q4.  How does your organization's risk culture affect where you set your HITL gates?</a:t>
             </a:r>
             <a:endParaRPr lang="en-US" sz="1150" dirty="0"/>
           </a:p>
@@ -13448,7 +13448,7 @@
                   <a:srgbClr val="FFFFFF"/>
                 </a:solidFill>
               </a:rPr>
-              <a:t>PROGRAMME SCOPE  ·  TWO KINDS OF AGENT</a:t>
+              <a:t>PROGRAM SCOPE  ·  TWO KINDS OF AGENT</a:t>
             </a:r>
             <a:endParaRPr lang="en-US" sz="1300" dirty="0"/>
           </a:p>

</xml_diff>